<commit_message>
format(align): sync all word and pdf assets with right-aligned accounting figures
</commit_message>
<xml_diff>
--- a/富宇大境6戶法定獨立分割與公款迎回提案說明會.pptx
+++ b/富宇大境6戶法定獨立分割與公款迎回提案說明會.pptx
@@ -112,1141 +112,6 @@
     </a:lvl9pPr>
   </p:defaultTextStyle>
 </p:presentation>
-</file>
-
-<file path=ppt/notesMasters/notesMaster1.xml><?xml version="1.0" encoding="utf-8"?>
-<p:notesMaster xmlns:a="http://schemas.openxmlformats.org/drawingml/2006/main" xmlns:p="http://schemas.openxmlformats.org/presentationml/2006/main" xmlns:r="http://schemas.openxmlformats.org/officeDocument/2006/relationships">
-  <p:cSld>
-    <p:bg>
-      <p:bgRef idx="1001">
-        <a:schemeClr val="bg1"/>
-      </p:bgRef>
-    </p:bg>
-    <p:spTree>
-      <p:nvGrpSpPr>
-        <p:cNvPr id="1" name=""/>
-        <p:cNvGrpSpPr/>
-        <p:nvPr/>
-      </p:nvGrpSpPr>
-      <p:grpSpPr>
-        <a:xfrm>
-          <a:off x="0" y="0"/>
-          <a:ext cx="0" cy="0"/>
-          <a:chOff x="0" y="0"/>
-          <a:chExt cx="0" cy="0"/>
-        </a:xfrm>
-      </p:grpSpPr>
-      <p:sp>
-        <p:nvSpPr>
-          <p:cNvPr id="2" name="Header Placeholder 1"/>
-          <p:cNvSpPr>
-            <a:spLocks noGrp="1"/>
-          </p:cNvSpPr>
-          <p:nvPr>
-            <p:ph type="hdr" sz="quarter"/>
-          </p:nvPr>
-        </p:nvSpPr>
-        <p:spPr>
-          <a:xfrm>
-            <a:off x="0" y="0"/>
-            <a:ext cx="2971800" cy="457200"/>
-          </a:xfrm>
-          <a:prstGeom prst="rect">
-            <a:avLst/>
-          </a:prstGeom>
-        </p:spPr>
-        <p:txBody>
-          <a:bodyPr vert="horz" lIns="91440" tIns="45720" rIns="91440" bIns="45720" rtlCol="0"/>
-          <a:lstStyle>
-            <a:lvl1pPr algn="l">
-              <a:defRPr sz="1200"/>
-            </a:lvl1pPr>
-          </a:lstStyle>
-          <a:p>
-            <a:endParaRPr lang="en-US"/>
-          </a:p>
-        </p:txBody>
-      </p:sp>
-      <p:sp>
-        <p:nvSpPr>
-          <p:cNvPr id="3" name="Date Placeholder 2"/>
-          <p:cNvSpPr>
-            <a:spLocks noGrp="1"/>
-          </p:cNvSpPr>
-          <p:nvPr>
-            <p:ph type="dt" idx="1"/>
-          </p:nvPr>
-        </p:nvSpPr>
-        <p:spPr>
-          <a:xfrm>
-            <a:off x="3884613" y="0"/>
-            <a:ext cx="2971800" cy="457200"/>
-          </a:xfrm>
-          <a:prstGeom prst="rect">
-            <a:avLst/>
-          </a:prstGeom>
-        </p:spPr>
-        <p:txBody>
-          <a:bodyPr vert="horz" lIns="91440" tIns="45720" rIns="91440" bIns="45720" rtlCol="0"/>
-          <a:lstStyle>
-            <a:lvl1pPr algn="r">
-              <a:defRPr sz="1200"/>
-            </a:lvl1pPr>
-          </a:lstStyle>
-          <a:p>
-            <a:fld id="{0F89C1C7-3DCD-1040-A9CF-14679D8B5DDD}" type="datetimeFigureOut">
-              <a:rPr lang="en-US" smtClean="0"/>
-              <a:t>10/17/16</a:t>
-            </a:fld>
-            <a:endParaRPr lang="en-US"/>
-          </a:p>
-        </p:txBody>
-      </p:sp>
-      <p:sp>
-        <p:nvSpPr>
-          <p:cNvPr id="4" name="Slide Image Placeholder 3"/>
-          <p:cNvSpPr>
-            <a:spLocks noGrp="1" noRot="1" noChangeAspect="1"/>
-          </p:cNvSpPr>
-          <p:nvPr>
-            <p:ph type="sldImg" idx="2"/>
-          </p:nvPr>
-        </p:nvSpPr>
-        <p:spPr>
-          <a:xfrm>
-            <a:off x="1143000" y="685800"/>
-            <a:ext cx="4572000" cy="3429000"/>
-          </a:xfrm>
-          <a:prstGeom prst="rect">
-            <a:avLst/>
-          </a:prstGeom>
-          <a:noFill/>
-          <a:ln w="12700">
-            <a:solidFill>
-              <a:prstClr val="black"/>
-            </a:solidFill>
-          </a:ln>
-        </p:spPr>
-        <p:txBody>
-          <a:bodyPr vert="horz" lIns="91440" tIns="45720" rIns="91440" bIns="45720" rtlCol="0" anchor="ctr"/>
-          <a:lstStyle/>
-          <a:p>
-            <a:endParaRPr lang="en-US"/>
-          </a:p>
-        </p:txBody>
-      </p:sp>
-      <p:sp>
-        <p:nvSpPr>
-          <p:cNvPr id="5" name="Notes Placeholder 4"/>
-          <p:cNvSpPr>
-            <a:spLocks noGrp="1"/>
-          </p:cNvSpPr>
-          <p:nvPr>
-            <p:ph type="body" sz="quarter" idx="3"/>
-          </p:nvPr>
-        </p:nvSpPr>
-        <p:spPr>
-          <a:xfrm>
-            <a:off x="685800" y="4343400"/>
-            <a:ext cx="5486400" cy="4114800"/>
-          </a:xfrm>
-          <a:prstGeom prst="rect">
-            <a:avLst/>
-          </a:prstGeom>
-        </p:spPr>
-        <p:txBody>
-          <a:bodyPr vert="horz" lIns="91440" tIns="45720" rIns="91440" bIns="45720" rtlCol="0"/>
-          <a:lstStyle/>
-          <a:p>
-            <a:pPr lvl="0"/>
-            <a:r>
-              <a:rPr lang="en-US" smtClean="0"/>
-              <a:t>Click to edit Master text styles</a:t>
-            </a:r>
-          </a:p>
-          <a:p>
-            <a:pPr lvl="1"/>
-            <a:r>
-              <a:rPr lang="en-US" smtClean="0"/>
-              <a:t>Second level</a:t>
-            </a:r>
-          </a:p>
-          <a:p>
-            <a:pPr lvl="2"/>
-            <a:r>
-              <a:rPr lang="en-US" smtClean="0"/>
-              <a:t>Third level</a:t>
-            </a:r>
-          </a:p>
-          <a:p>
-            <a:pPr lvl="3"/>
-            <a:r>
-              <a:rPr lang="en-US" smtClean="0"/>
-              <a:t>Fourth level</a:t>
-            </a:r>
-          </a:p>
-          <a:p>
-            <a:pPr lvl="4"/>
-            <a:r>
-              <a:rPr lang="en-US" smtClean="0"/>
-              <a:t>Fifth level</a:t>
-            </a:r>
-            <a:endParaRPr lang="en-US"/>
-          </a:p>
-        </p:txBody>
-      </p:sp>
-      <p:sp>
-        <p:nvSpPr>
-          <p:cNvPr id="6" name="Footer Placeholder 5"/>
-          <p:cNvSpPr>
-            <a:spLocks noGrp="1"/>
-          </p:cNvSpPr>
-          <p:nvPr>
-            <p:ph type="ftr" sz="quarter" idx="4"/>
-          </p:nvPr>
-        </p:nvSpPr>
-        <p:spPr>
-          <a:xfrm>
-            <a:off x="0" y="8685213"/>
-            <a:ext cx="2971800" cy="457200"/>
-          </a:xfrm>
-          <a:prstGeom prst="rect">
-            <a:avLst/>
-          </a:prstGeom>
-        </p:spPr>
-        <p:txBody>
-          <a:bodyPr vert="horz" lIns="91440" tIns="45720" rIns="91440" bIns="45720" rtlCol="0" anchor="b"/>
-          <a:lstStyle>
-            <a:lvl1pPr algn="l">
-              <a:defRPr sz="1200"/>
-            </a:lvl1pPr>
-          </a:lstStyle>
-          <a:p>
-            <a:endParaRPr lang="en-US"/>
-          </a:p>
-        </p:txBody>
-      </p:sp>
-      <p:sp>
-        <p:nvSpPr>
-          <p:cNvPr id="7" name="Slide Number Placeholder 6"/>
-          <p:cNvSpPr>
-            <a:spLocks noGrp="1"/>
-          </p:cNvSpPr>
-          <p:nvPr>
-            <p:ph type="sldNum" sz="quarter" idx="5"/>
-          </p:nvPr>
-        </p:nvSpPr>
-        <p:spPr>
-          <a:xfrm>
-            <a:off x="3884613" y="8685213"/>
-            <a:ext cx="2971800" cy="457200"/>
-          </a:xfrm>
-          <a:prstGeom prst="rect">
-            <a:avLst/>
-          </a:prstGeom>
-        </p:spPr>
-        <p:txBody>
-          <a:bodyPr vert="horz" lIns="91440" tIns="45720" rIns="91440" bIns="45720" rtlCol="0" anchor="b"/>
-          <a:lstStyle>
-            <a:lvl1pPr algn="r">
-              <a:defRPr sz="1200"/>
-            </a:lvl1pPr>
-          </a:lstStyle>
-          <a:p>
-            <a:fld id="{BB5E49A5-4136-284D-997B-48E1D791AD67}" type="slidenum">
-              <a:rPr lang="en-US" smtClean="0"/>
-              <a:t>‹#›</a:t>
-            </a:fld>
-            <a:endParaRPr lang="en-US"/>
-          </a:p>
-        </p:txBody>
-      </p:sp>
-    </p:spTree>
-    <p:extLst>
-      <p:ext uri="{BB962C8B-B14F-4D97-AF65-F5344CB8AC3E}">
-        <p14:creationId xmlns:p14="http://schemas.microsoft.com/office/powerpoint/2010/main" val="2623252185"/>
-      </p:ext>
-    </p:extLst>
-  </p:cSld>
-  <p:clrMap bg1="lt1" tx1="dk1" bg2="lt2" tx2="dk2" accent1="accent1" accent2="accent2" accent3="accent3" accent4="accent4" accent5="accent5" accent6="accent6" hlink="hlink" folHlink="folHlink"/>
-  <p:notesStyle>
-    <a:lvl1pPr marL="0" algn="l" defTabSz="457200" rtl="0" eaLnBrk="1" latinLnBrk="0" hangingPunct="1">
-      <a:defRPr sz="1200" kern="1200">
-        <a:solidFill>
-          <a:schemeClr val="tx1"/>
-        </a:solidFill>
-        <a:latin typeface="+mn-lt"/>
-        <a:ea typeface="+mn-ea"/>
-        <a:cs typeface="+mn-cs"/>
-      </a:defRPr>
-    </a:lvl1pPr>
-    <a:lvl2pPr marL="457200" algn="l" defTabSz="457200" rtl="0" eaLnBrk="1" latinLnBrk="0" hangingPunct="1">
-      <a:defRPr sz="1200" kern="1200">
-        <a:solidFill>
-          <a:schemeClr val="tx1"/>
-        </a:solidFill>
-        <a:latin typeface="+mn-lt"/>
-        <a:ea typeface="+mn-ea"/>
-        <a:cs typeface="+mn-cs"/>
-      </a:defRPr>
-    </a:lvl2pPr>
-    <a:lvl3pPr marL="914400" algn="l" defTabSz="457200" rtl="0" eaLnBrk="1" latinLnBrk="0" hangingPunct="1">
-      <a:defRPr sz="1200" kern="1200">
-        <a:solidFill>
-          <a:schemeClr val="tx1"/>
-        </a:solidFill>
-        <a:latin typeface="+mn-lt"/>
-        <a:ea typeface="+mn-ea"/>
-        <a:cs typeface="+mn-cs"/>
-      </a:defRPr>
-    </a:lvl3pPr>
-    <a:lvl4pPr marL="1371600" algn="l" defTabSz="457200" rtl="0" eaLnBrk="1" latinLnBrk="0" hangingPunct="1">
-      <a:defRPr sz="1200" kern="1200">
-        <a:solidFill>
-          <a:schemeClr val="tx1"/>
-        </a:solidFill>
-        <a:latin typeface="+mn-lt"/>
-        <a:ea typeface="+mn-ea"/>
-        <a:cs typeface="+mn-cs"/>
-      </a:defRPr>
-    </a:lvl4pPr>
-    <a:lvl5pPr marL="1828800" algn="l" defTabSz="457200" rtl="0" eaLnBrk="1" latinLnBrk="0" hangingPunct="1">
-      <a:defRPr sz="1200" kern="1200">
-        <a:solidFill>
-          <a:schemeClr val="tx1"/>
-        </a:solidFill>
-        <a:latin typeface="+mn-lt"/>
-        <a:ea typeface="+mn-ea"/>
-        <a:cs typeface="+mn-cs"/>
-      </a:defRPr>
-    </a:lvl5pPr>
-    <a:lvl6pPr marL="2286000" algn="l" defTabSz="457200" rtl="0" eaLnBrk="1" latinLnBrk="0" hangingPunct="1">
-      <a:defRPr sz="1200" kern="1200">
-        <a:solidFill>
-          <a:schemeClr val="tx1"/>
-        </a:solidFill>
-        <a:latin typeface="+mn-lt"/>
-        <a:ea typeface="+mn-ea"/>
-        <a:cs typeface="+mn-cs"/>
-      </a:defRPr>
-    </a:lvl6pPr>
-    <a:lvl7pPr marL="2743200" algn="l" defTabSz="457200" rtl="0" eaLnBrk="1" latinLnBrk="0" hangingPunct="1">
-      <a:defRPr sz="1200" kern="1200">
-        <a:solidFill>
-          <a:schemeClr val="tx1"/>
-        </a:solidFill>
-        <a:latin typeface="+mn-lt"/>
-        <a:ea typeface="+mn-ea"/>
-        <a:cs typeface="+mn-cs"/>
-      </a:defRPr>
-    </a:lvl7pPr>
-    <a:lvl8pPr marL="3200400" algn="l" defTabSz="457200" rtl="0" eaLnBrk="1" latinLnBrk="0" hangingPunct="1">
-      <a:defRPr sz="1200" kern="1200">
-        <a:solidFill>
-          <a:schemeClr val="tx1"/>
-        </a:solidFill>
-        <a:latin typeface="+mn-lt"/>
-        <a:ea typeface="+mn-ea"/>
-        <a:cs typeface="+mn-cs"/>
-      </a:defRPr>
-    </a:lvl8pPr>
-    <a:lvl9pPr marL="3657600" algn="l" defTabSz="457200" rtl="0" eaLnBrk="1" latinLnBrk="0" hangingPunct="1">
-      <a:defRPr sz="1200" kern="1200">
-        <a:solidFill>
-          <a:schemeClr val="tx1"/>
-        </a:solidFill>
-        <a:latin typeface="+mn-lt"/>
-        <a:ea typeface="+mn-ea"/>
-        <a:cs typeface="+mn-cs"/>
-      </a:defRPr>
-    </a:lvl9pPr>
-  </p:notesStyle>
-</p:notesMaster>
-</file>
-
-<file path=ppt/notesSlides/notesSlide1.xml><?xml version="1.0" encoding="utf-8"?>
-<p:notes xmlns:a="http://schemas.openxmlformats.org/drawingml/2006/main" xmlns:p="http://schemas.openxmlformats.org/presentationml/2006/main" xmlns:r="http://schemas.openxmlformats.org/officeDocument/2006/relationships">
-  <p:cSld>
-    <p:spTree>
-      <p:nvGrpSpPr>
-        <p:cNvPr id="1" name=""/>
-        <p:cNvGrpSpPr/>
-        <p:nvPr/>
-      </p:nvGrpSpPr>
-      <p:grpSpPr>
-        <a:xfrm>
-          <a:off x="0" y="0"/>
-          <a:ext cx="0" cy="0"/>
-          <a:chOff x="0" y="0"/>
-          <a:chExt cx="0" cy="0"/>
-        </a:xfrm>
-      </p:grpSpPr>
-      <p:sp>
-        <p:nvSpPr>
-          <p:cNvPr id="2" name="Slide Image Placeholder 1"/>
-          <p:cNvSpPr>
-            <a:spLocks noGrp="1"/>
-          </p:cNvSpPr>
-          <p:nvPr>
-            <p:ph type="sldImg" idx="2"/>
-          </p:nvPr>
-        </p:nvSpPr>
-        <p:spPr/>
-      </p:sp>
-      <p:sp>
-        <p:nvSpPr>
-          <p:cNvPr id="3" name="Notes Placeholder 2"/>
-          <p:cNvSpPr>
-            <a:spLocks noGrp="1"/>
-          </p:cNvSpPr>
-          <p:nvPr>
-            <p:ph type="body" idx="3" sz="quarter"/>
-          </p:nvPr>
-        </p:nvSpPr>
-        <p:spPr/>
-        <p:txBody>
-          <a:bodyPr/>
-          <a:lstStyle/>
-          <a:p>
-            <a:r>
-              <a:t>【Slide 1 講者開場口述重點（廖倫豪）】</a:t>
-            </a:r>
-          </a:p>
-          <a:p>
-            <a:r>
-              <a:t>各位鄰居、大哥大姐大家晚安，感謝大家今天撥空聚在客廳。我是 595 號 A17 的廖倫豪。</a:t>
-            </a:r>
-          </a:p>
-          <a:p>
-            <a:r>
-              <a:t>今天請大家聚在一起，不是要製造任何糾紛，而是要跟各位報告一個攸關我們 6 戶重大切身權益的事實。</a:t>
-            </a:r>
-          </a:p>
-          <a:p>
-            <a:r>
-              <a:t>我們住在最外側臨龍社路這排，長年以來，我們每個月繳的管理費，大部分都在補貼大社區內部深處的開銷。</a:t>
-            </a:r>
-          </a:p>
-          <a:p>
-            <a:r>
-              <a:t>我花了幾週時間，把管委會這幾個月的財務報表、地籍圖和法規全部調閱審查完畢，確認依據《公寓大廈管理條例》第 26 條，我們 100% 具備獨立分割條件。</a:t>
-            </a:r>
-          </a:p>
-          <a:p>
-            <a:r>
-              <a:t>最重要的是：我們只要依法分家，帳上立刻能迎回 28 萬 4 千多塊的自有公款，每個月管理費還能從 1,000 元直接降到 400 元，生活更有自主尊嚴！</a:t>
-            </a:r>
-          </a:p>
-        </p:txBody>
-      </p:sp>
-      <p:sp>
-        <p:nvSpPr>
-          <p:cNvPr id="4" name="Slide Number Placeholder 3"/>
-          <p:cNvSpPr>
-            <a:spLocks noGrp="1"/>
-          </p:cNvSpPr>
-          <p:nvPr>
-            <p:ph type="sldNum" idx="5" sz="quarter"/>
-          </p:nvPr>
-        </p:nvSpPr>
-        <p:spPr/>
-      </p:sp>
-    </p:spTree>
-  </p:cSld>
-  <p:clrMapOvr>
-    <a:masterClrMapping/>
-  </p:clrMapOvr>
-</p:notes>
-</file>
-
-<file path=ppt/notesSlides/notesSlide2.xml><?xml version="1.0" encoding="utf-8"?>
-<p:notes xmlns:a="http://schemas.openxmlformats.org/drawingml/2006/main" xmlns:p="http://schemas.openxmlformats.org/presentationml/2006/main" xmlns:r="http://schemas.openxmlformats.org/officeDocument/2006/relationships">
-  <p:cSld>
-    <p:spTree>
-      <p:nvGrpSpPr>
-        <p:cNvPr id="1" name=""/>
-        <p:cNvGrpSpPr/>
-        <p:nvPr/>
-      </p:nvGrpSpPr>
-      <p:grpSpPr>
-        <a:xfrm>
-          <a:off x="0" y="0"/>
-          <a:ext cx="0" cy="0"/>
-          <a:chOff x="0" y="0"/>
-          <a:chExt cx="0" cy="0"/>
-        </a:xfrm>
-      </p:grpSpPr>
-      <p:sp>
-        <p:nvSpPr>
-          <p:cNvPr id="2" name="Slide Image Placeholder 1"/>
-          <p:cNvSpPr>
-            <a:spLocks noGrp="1"/>
-          </p:cNvSpPr>
-          <p:nvPr>
-            <p:ph type="sldImg" idx="2"/>
-          </p:nvPr>
-        </p:nvSpPr>
-        <p:spPr/>
-      </p:sp>
-      <p:sp>
-        <p:nvSpPr>
-          <p:cNvPr id="3" name="Notes Placeholder 2"/>
-          <p:cNvSpPr>
-            <a:spLocks noGrp="1"/>
-          </p:cNvSpPr>
-          <p:nvPr>
-            <p:ph type="body" idx="3" sz="quarter"/>
-          </p:nvPr>
-        </p:nvSpPr>
-        <p:spPr/>
-        <p:txBody>
-          <a:bodyPr/>
-          <a:lstStyle/>
-          <a:p>
-            <a:r>
-              <a:t>【Slide 2 痛點剖析口述重點】</a:t>
-            </a:r>
-          </a:p>
-          <a:p>
-            <a:r>
-              <a:t>大家請看這張投影片，這就是我們 6 戶目前的真實處境：</a:t>
-            </a:r>
-          </a:p>
-          <a:p>
-            <a:r>
-              <a:t>第一，全社區 241 戶，我們只有 6 戶，在管委會根本沒有席次，說話沒有人聽。</a:t>
-            </a:r>
-          </a:p>
-          <a:p>
-            <a:r>
-              <a:t>第二，我們 6 戶每年總共繳交 7 萬 2 千塊管理費，這筆錢全被拿去支應大社區深處巷道的維護與開銷。</a:t>
-            </a:r>
-          </a:p>
-          <a:p>
-            <a:r>
-              <a:t>第三，最不合理的是：內部垃圾子母車一個月要花 4 萬 8 千元，我們大境 6 戶門前就有市府免費垃圾車，大家都是自己等垃圾車，根本沒用子母車，為什麼每個月要替別人分攤？</a:t>
-            </a:r>
-          </a:p>
-          <a:p>
-            <a:r>
-              <a:t>第四，物業經理每個月領 7 萬多薪水，常駐在裡面的貨櫃屋，我們門前連包裹代收都沒有，享受到的服務近乎為零。我們等於是在當冤大頭！</a:t>
-            </a:r>
-          </a:p>
-        </p:txBody>
-      </p:sp>
-      <p:sp>
-        <p:nvSpPr>
-          <p:cNvPr id="4" name="Slide Number Placeholder 3"/>
-          <p:cNvSpPr>
-            <a:spLocks noGrp="1"/>
-          </p:cNvSpPr>
-          <p:nvPr>
-            <p:ph type="sldNum" idx="5" sz="quarter"/>
-          </p:nvPr>
-        </p:nvSpPr>
-        <p:spPr/>
-      </p:sp>
-    </p:spTree>
-  </p:cSld>
-  <p:clrMapOvr>
-    <a:masterClrMapping/>
-  </p:clrMapOvr>
-</p:notes>
-</file>
-
-<file path=ppt/notesSlides/notesSlide3.xml><?xml version="1.0" encoding="utf-8"?>
-<p:notes xmlns:a="http://schemas.openxmlformats.org/drawingml/2006/main" xmlns:p="http://schemas.openxmlformats.org/presentationml/2006/main" xmlns:r="http://schemas.openxmlformats.org/officeDocument/2006/relationships">
-  <p:cSld>
-    <p:spTree>
-      <p:nvGrpSpPr>
-        <p:cNvPr id="1" name=""/>
-        <p:cNvGrpSpPr/>
-        <p:nvPr/>
-      </p:nvGrpSpPr>
-      <p:grpSpPr>
-        <a:xfrm>
-          <a:off x="0" y="0"/>
-          <a:ext cx="0" cy="0"/>
-          <a:chOff x="0" y="0"/>
-          <a:chExt cx="0" cy="0"/>
-        </a:xfrm>
-      </p:grpSpPr>
-      <p:sp>
-        <p:nvSpPr>
-          <p:cNvPr id="2" name="Slide Image Placeholder 1"/>
-          <p:cNvSpPr>
-            <a:spLocks noGrp="1"/>
-          </p:cNvSpPr>
-          <p:nvPr>
-            <p:ph type="sldImg" idx="2"/>
-          </p:nvPr>
-        </p:nvSpPr>
-        <p:spPr/>
-      </p:sp>
-      <p:sp>
-        <p:nvSpPr>
-          <p:cNvPr id="3" name="Notes Placeholder 2"/>
-          <p:cNvSpPr>
-            <a:spLocks noGrp="1"/>
-          </p:cNvSpPr>
-          <p:nvPr>
-            <p:ph type="body" idx="3" sz="quarter"/>
-          </p:nvPr>
-        </p:nvSpPr>
-        <p:spPr/>
-        <p:txBody>
-          <a:bodyPr/>
-          <a:lstStyle/>
-          <a:p>
-            <a:r>
-              <a:t>【Slide 3 法律三大王牌口述重點】</a:t>
-            </a:r>
-          </a:p>
-          <a:p>
-            <a:r>
-              <a:t>有些鄰居可能會擔心：大社區會不會不放人？我們才 6 戶能打得贏嗎？</a:t>
-            </a:r>
-          </a:p>
-          <a:p>
-            <a:r>
-              <a:t>請大家放一百個心！我查過所有法律判例與法條，依據《公寓大廈管理條例》第 26 條第 1 項，我們手握三大王牌：</a:t>
-            </a:r>
-          </a:p>
-          <a:p>
-            <a:r>
-              <a:t>王牌一：我們的出入直接面臨公有計畫道路龍社路，根本不經過大社區裡面的 642 巷或任何私設巷道，地緣 100% 獨立！</a:t>
-            </a:r>
-          </a:p>
-          <a:p>
-            <a:r>
-              <a:t>王牌二：我們生活垃圾自己等免費垃圾車，只要我們出具《環保自理切結書》，自願放棄使用大社區子母車，法規上所謂『公設不可分』的藉口直接瓦解！</a:t>
-            </a:r>
-          </a:p>
-          <a:p>
-            <a:r>
-              <a:t>王牌三：管委會在新光銀行開的定存專戶裡，早就把『A2 大境定存單』獨立開立成一張 22 萬 231 元的存單。產權原本就是我們的，誰也賴不掉！</a:t>
-            </a:r>
-          </a:p>
-        </p:txBody>
-      </p:sp>
-      <p:sp>
-        <p:nvSpPr>
-          <p:cNvPr id="4" name="Slide Number Placeholder 3"/>
-          <p:cNvSpPr>
-            <a:spLocks noGrp="1"/>
-          </p:cNvSpPr>
-          <p:nvPr>
-            <p:ph type="sldNum" idx="5" sz="quarter"/>
-          </p:nvPr>
-        </p:nvSpPr>
-        <p:spPr/>
-      </p:sp>
-    </p:spTree>
-  </p:cSld>
-  <p:clrMapOvr>
-    <a:masterClrMapping/>
-  </p:clrMapOvr>
-</p:notes>
-</file>
-
-<file path=ppt/notesSlides/notesSlide4.xml><?xml version="1.0" encoding="utf-8"?>
-<p:notes xmlns:a="http://schemas.openxmlformats.org/drawingml/2006/main" xmlns:p="http://schemas.openxmlformats.org/presentationml/2006/main" xmlns:r="http://schemas.openxmlformats.org/officeDocument/2006/relationships">
-  <p:cSld>
-    <p:spTree>
-      <p:nvGrpSpPr>
-        <p:cNvPr id="1" name=""/>
-        <p:cNvGrpSpPr/>
-        <p:nvPr/>
-      </p:nvGrpSpPr>
-      <p:grpSpPr>
-        <a:xfrm>
-          <a:off x="0" y="0"/>
-          <a:ext cx="0" cy="0"/>
-          <a:chOff x="0" y="0"/>
-          <a:chExt cx="0" cy="0"/>
-        </a:xfrm>
-      </p:grpSpPr>
-      <p:sp>
-        <p:nvSpPr>
-          <p:cNvPr id="2" name="Slide Image Placeholder 1"/>
-          <p:cNvSpPr>
-            <a:spLocks noGrp="1"/>
-          </p:cNvSpPr>
-          <p:nvPr>
-            <p:ph type="sldImg" idx="2"/>
-          </p:nvPr>
-        </p:nvSpPr>
-        <p:spPr/>
-      </p:sp>
-      <p:sp>
-        <p:nvSpPr>
-          <p:cNvPr id="3" name="Notes Placeholder 2"/>
-          <p:cNvSpPr>
-            <a:spLocks noGrp="1"/>
-          </p:cNvSpPr>
-          <p:nvPr>
-            <p:ph type="body" idx="3" sz="quarter"/>
-          </p:nvPr>
-        </p:nvSpPr>
-        <p:spPr/>
-        <p:txBody>
-          <a:bodyPr/>
-          <a:lstStyle/>
-          <a:p>
-            <a:r>
-              <a:t>【Slide 4 資產清算與公款迎回口述重點】</a:t>
-            </a:r>
-          </a:p>
-          <a:p>
-            <a:r>
-              <a:t>大家最關心的財務問題：我們分家能拿回多少錢？</a:t>
-            </a:r>
-          </a:p>
-          <a:p>
-            <a:r>
-              <a:t>請看這份清算表，白紙黑字全部有會議記錄佐證：</a:t>
-            </a:r>
-          </a:p>
-          <a:p>
-            <a:r>
-              <a:t>第一筆：新光銀行 A2 大境定存單本金 220,231 元，加上孳生利息。</a:t>
-            </a:r>
-          </a:p>
-          <a:p>
-            <a:r>
-              <a:t>第二筆：富宇建設交屋時移交的管理基金，全社區 241 萬，我們 6 戶每戶 1 萬，依法應退還 60,000 元！</a:t>
-            </a:r>
-          </a:p>
-          <a:p>
-            <a:r>
-              <a:t>第三筆：5 到 9 月份我們繳的管理費，扣除門前路燈公電後的結餘款約 4,500 元。</a:t>
-            </a:r>
-          </a:p>
-          <a:p>
-            <a:r>
-              <a:t>合計我們大境獨立後，帳上一次性就能迎回 NT$ 284,731 元整！</a:t>
-            </a:r>
-          </a:p>
-          <a:p>
-            <a:r>
-              <a:t>平均每一戶享有將近 4 萬 8 千元的公款儲備，未來門前路燈維護、局部公設修繕，這筆老本足夠我們用 10 年以上！</a:t>
-            </a:r>
-          </a:p>
-        </p:txBody>
-      </p:sp>
-      <p:sp>
-        <p:nvSpPr>
-          <p:cNvPr id="4" name="Slide Number Placeholder 3"/>
-          <p:cNvSpPr>
-            <a:spLocks noGrp="1"/>
-          </p:cNvSpPr>
-          <p:nvPr>
-            <p:ph type="sldNum" idx="5" sz="quarter"/>
-          </p:nvPr>
-        </p:nvSpPr>
-        <p:spPr/>
-      </p:sp>
-    </p:spTree>
-  </p:cSld>
-  <p:clrMapOvr>
-    <a:masterClrMapping/>
-  </p:clrMapOvr>
-</p:notes>
-</file>
-
-<file path=ppt/notesSlides/notesSlide5.xml><?xml version="1.0" encoding="utf-8"?>
-<p:notes xmlns:a="http://schemas.openxmlformats.org/drawingml/2006/main" xmlns:p="http://schemas.openxmlformats.org/presentationml/2006/main" xmlns:r="http://schemas.openxmlformats.org/officeDocument/2006/relationships">
-  <p:cSld>
-    <p:spTree>
-      <p:nvGrpSpPr>
-        <p:cNvPr id="1" name=""/>
-        <p:cNvGrpSpPr/>
-        <p:nvPr/>
-      </p:nvGrpSpPr>
-      <p:grpSpPr>
-        <a:xfrm>
-          <a:off x="0" y="0"/>
-          <a:ext cx="0" cy="0"/>
-          <a:chOff x="0" y="0"/>
-          <a:chExt cx="0" cy="0"/>
-        </a:xfrm>
-      </p:grpSpPr>
-      <p:sp>
-        <p:nvSpPr>
-          <p:cNvPr id="2" name="Slide Image Placeholder 1"/>
-          <p:cNvSpPr>
-            <a:spLocks noGrp="1"/>
-          </p:cNvSpPr>
-          <p:nvPr>
-            <p:ph type="sldImg" idx="2"/>
-          </p:nvPr>
-        </p:nvSpPr>
-        <p:spPr/>
-      </p:sp>
-      <p:sp>
-        <p:nvSpPr>
-          <p:cNvPr id="3" name="Notes Placeholder 2"/>
-          <p:cNvSpPr>
-            <a:spLocks noGrp="1"/>
-          </p:cNvSpPr>
-          <p:nvPr>
-            <p:ph type="body" idx="3" sz="quarter"/>
-          </p:nvPr>
-        </p:nvSpPr>
-        <p:spPr/>
-        <p:txBody>
-          <a:bodyPr/>
-          <a:lstStyle/>
-          <a:p>
-            <a:r>
-              <a:t>【Slide 5 管理費降至 400 元口述重點】</a:t>
-            </a:r>
-          </a:p>
-          <a:p>
-            <a:r>
-              <a:t>分家之後，我們的日常開銷極度單純：</a:t>
-            </a:r>
-          </a:p>
-          <a:p>
-            <a:r>
-              <a:t>我們每戶每個月的管理費，我建議直接調降到 400 元！每戶每年現省 7,200 元。</a:t>
-            </a:r>
-          </a:p>
-          <a:p>
-            <a:r>
-              <a:t>6 戶一個月收 2,400 元，一年有 28,800 元。</a:t>
-            </a:r>
-          </a:p>
-          <a:p>
-            <a:r>
-              <a:t>我們的支出只有門前路燈電費（每月約 400 元）和開戶行政郵資（每月約 200 元），垃圾清潔隊免費收，垃圾費是 0 元！</a:t>
-            </a:r>
-          </a:p>
-          <a:p>
-            <a:r>
-              <a:t>算下來，我們每個月還倒賺 1,800 元，一年能存下 21,600 元儲備金。</a:t>
-            </a:r>
-          </a:p>
-          <a:p>
-            <a:r>
-              <a:t>帳上本來就有 28 萬老本在銀行生利息，每年還能多存 2 萬多塊，財務非常健康自由！</a:t>
-            </a:r>
-          </a:p>
-        </p:txBody>
-      </p:sp>
-      <p:sp>
-        <p:nvSpPr>
-          <p:cNvPr id="4" name="Slide Number Placeholder 3"/>
-          <p:cNvSpPr>
-            <a:spLocks noGrp="1"/>
-          </p:cNvSpPr>
-          <p:nvPr>
-            <p:ph type="sldNum" idx="5" sz="quarter"/>
-          </p:nvPr>
-        </p:nvSpPr>
-        <p:spPr/>
-      </p:sp>
-    </p:spTree>
-  </p:cSld>
-  <p:clrMapOvr>
-    <a:masterClrMapping/>
-  </p:clrMapOvr>
-</p:notes>
-</file>
-
-<file path=ppt/notesSlides/notesSlide6.xml><?xml version="1.0" encoding="utf-8"?>
-<p:notes xmlns:a="http://schemas.openxmlformats.org/drawingml/2006/main" xmlns:p="http://schemas.openxmlformats.org/presentationml/2006/main" xmlns:r="http://schemas.openxmlformats.org/officeDocument/2006/relationships">
-  <p:cSld>
-    <p:spTree>
-      <p:nvGrpSpPr>
-        <p:cNvPr id="1" name=""/>
-        <p:cNvGrpSpPr/>
-        <p:nvPr/>
-      </p:nvGrpSpPr>
-      <p:grpSpPr>
-        <a:xfrm>
-          <a:off x="0" y="0"/>
-          <a:ext cx="0" cy="0"/>
-          <a:chOff x="0" y="0"/>
-          <a:chExt cx="0" cy="0"/>
-        </a:xfrm>
-      </p:grpSpPr>
-      <p:sp>
-        <p:nvSpPr>
-          <p:cNvPr id="2" name="Slide Image Placeholder 1"/>
-          <p:cNvSpPr>
-            <a:spLocks noGrp="1"/>
-          </p:cNvSpPr>
-          <p:nvPr>
-            <p:ph type="sldImg" idx="2"/>
-          </p:nvPr>
-        </p:nvSpPr>
-        <p:spPr/>
-      </p:sp>
-      <p:sp>
-        <p:nvSpPr>
-          <p:cNvPr id="3" name="Notes Placeholder 2"/>
-          <p:cNvSpPr>
-            <a:spLocks noGrp="1"/>
-          </p:cNvSpPr>
-          <p:nvPr>
-            <p:ph type="body" idx="3" sz="quarter"/>
-          </p:nvPr>
-        </p:nvSpPr>
-        <p:spPr/>
-        <p:txBody>
-          <a:bodyPr/>
-          <a:lstStyle/>
-          <a:p>
-            <a:r>
-              <a:t>【Slide 6 五大推動步驟口述重點】</a:t>
-            </a:r>
-          </a:p>
-          <a:p>
-            <a:r>
-              <a:t>推動程序非常清晰，完全依內政部標準 SOP 辦理：</a:t>
-            </a:r>
-          </a:p>
-          <a:p>
-            <a:r>
-              <a:t>第一步：今天我們 6 戶達成 100% 共識，大家簽署連署書。</a:t>
-            </a:r>
-          </a:p>
-          <a:p>
-            <a:r>
-              <a:t>第二步：由我代表大家，正式以書面公文向富宇大地管委會例會提案。</a:t>
-            </a:r>
-          </a:p>
-          <a:p>
-            <a:r>
-              <a:t>第三步：管委會確認獨立，雙方簽署《資產分割清算協議書》，把 28 萬專款移交。</a:t>
-            </a:r>
-          </a:p>
-          <a:p>
-            <a:r>
-              <a:t>第四步：我們備齊公文規約向台中市龍井區公所報備，大社區變更為 235 戶，大境核准為 6 戶獨立管委會並取得新統一編號。</a:t>
-            </a:r>
-          </a:p>
-          <a:p>
-            <a:r>
-              <a:t>第五步：我們拿著公所公文到新光銀行開立專戶，28 萬公款全額入帳，正式開始獨立自治！</a:t>
-            </a:r>
-          </a:p>
-        </p:txBody>
-      </p:sp>
-      <p:sp>
-        <p:nvSpPr>
-          <p:cNvPr id="4" name="Slide Number Placeholder 3"/>
-          <p:cNvSpPr>
-            <a:spLocks noGrp="1"/>
-          </p:cNvSpPr>
-          <p:nvPr>
-            <p:ph type="sldNum" idx="5" sz="quarter"/>
-          </p:nvPr>
-        </p:nvSpPr>
-        <p:spPr/>
-      </p:sp>
-    </p:spTree>
-  </p:cSld>
-  <p:clrMapOvr>
-    <a:masterClrMapping/>
-  </p:clrMapOvr>
-</p:notes>
-</file>
-
-<file path=ppt/notesSlides/notesSlide7.xml><?xml version="1.0" encoding="utf-8"?>
-<p:notes xmlns:a="http://schemas.openxmlformats.org/drawingml/2006/main" xmlns:p="http://schemas.openxmlformats.org/presentationml/2006/main" xmlns:r="http://schemas.openxmlformats.org/officeDocument/2006/relationships">
-  <p:cSld>
-    <p:spTree>
-      <p:nvGrpSpPr>
-        <p:cNvPr id="1" name=""/>
-        <p:cNvGrpSpPr/>
-        <p:nvPr/>
-      </p:nvGrpSpPr>
-      <p:grpSpPr>
-        <a:xfrm>
-          <a:off x="0" y="0"/>
-          <a:ext cx="0" cy="0"/>
-          <a:chOff x="0" y="0"/>
-          <a:chExt cx="0" cy="0"/>
-        </a:xfrm>
-      </p:grpSpPr>
-      <p:sp>
-        <p:nvSpPr>
-          <p:cNvPr id="2" name="Slide Image Placeholder 1"/>
-          <p:cNvSpPr>
-            <a:spLocks noGrp="1"/>
-          </p:cNvSpPr>
-          <p:nvPr>
-            <p:ph type="sldImg" idx="2"/>
-          </p:nvPr>
-        </p:nvSpPr>
-        <p:spPr/>
-      </p:sp>
-      <p:sp>
-        <p:nvSpPr>
-          <p:cNvPr id="3" name="Notes Placeholder 2"/>
-          <p:cNvSpPr>
-            <a:spLocks noGrp="1"/>
-          </p:cNvSpPr>
-          <p:nvPr>
-            <p:ph type="body" idx="3" sz="quarter"/>
-          </p:nvPr>
-        </p:nvSpPr>
-        <p:spPr/>
-        <p:txBody>
-          <a:bodyPr/>
-          <a:lstStyle/>
-          <a:p>
-            <a:r>
-              <a:t>【Slide 7 今日行動與受託承諾口述重點】</a:t>
-            </a:r>
-          </a:p>
-          <a:p>
-            <a:r>
-              <a:t>各位鄰居，今天最關鍵的第一步，就是我們 6 戶的心要齊：</a:t>
-            </a:r>
-          </a:p>
-          <a:p>
-            <a:r>
-              <a:t>發動提案，只需要我們 6 戶在申請書上簽名，完全不需要找大社區任何人簽名！</a:t>
-            </a:r>
-          </a:p>
-          <a:p>
-            <a:r>
-              <a:t>我廖倫豪在此向全體鄰居鄭重承諾：</a:t>
-            </a:r>
-          </a:p>
-          <a:p>
-            <a:r>
-              <a:t>第一，全套法律公文、可行性報告書、地籍圖、協議書我都已經以最嚴謹標準編制完畢。</a:t>
-            </a:r>
-          </a:p>
-          <a:p>
-            <a:r>
-              <a:t>第二，由我擔任受託召集人，代表大家出席交涉與公所送件，大家不需要操心繁瑣公務。</a:t>
-            </a:r>
-          </a:p>
-          <a:p>
-            <a:r>
-              <a:t>第三，帳目絕對透明，每一分公款全數進入大境專戶，絕無私挪。</a:t>
-            </a:r>
-          </a:p>
-          <a:p>
-            <a:r>
-              <a:t>各位鄰居只要安心簽名，我們就能把原本屬於我們的自主權與公款拿回來！</a:t>
-            </a:r>
-          </a:p>
-        </p:txBody>
-      </p:sp>
-      <p:sp>
-        <p:nvSpPr>
-          <p:cNvPr id="4" name="Slide Number Placeholder 3"/>
-          <p:cNvSpPr>
-            <a:spLocks noGrp="1"/>
-          </p:cNvSpPr>
-          <p:nvPr>
-            <p:ph type="sldNum" idx="5" sz="quarter"/>
-          </p:nvPr>
-        </p:nvSpPr>
-        <p:spPr/>
-      </p:sp>
-    </p:spTree>
-  </p:cSld>
-  <p:clrMapOvr>
-    <a:masterClrMapping/>
-  </p:clrMapOvr>
-</p:notes>
-</file>
-
-<file path=ppt/notesSlides/notesSlide8.xml><?xml version="1.0" encoding="utf-8"?>
-<p:notes xmlns:a="http://schemas.openxmlformats.org/drawingml/2006/main" xmlns:p="http://schemas.openxmlformats.org/presentationml/2006/main" xmlns:r="http://schemas.openxmlformats.org/officeDocument/2006/relationships">
-  <p:cSld>
-    <p:spTree>
-      <p:nvGrpSpPr>
-        <p:cNvPr id="1" name=""/>
-        <p:cNvGrpSpPr/>
-        <p:nvPr/>
-      </p:nvGrpSpPr>
-      <p:grpSpPr>
-        <a:xfrm>
-          <a:off x="0" y="0"/>
-          <a:ext cx="0" cy="0"/>
-          <a:chOff x="0" y="0"/>
-          <a:chExt cx="0" cy="0"/>
-        </a:xfrm>
-      </p:grpSpPr>
-      <p:sp>
-        <p:nvSpPr>
-          <p:cNvPr id="2" name="Slide Image Placeholder 1"/>
-          <p:cNvSpPr>
-            <a:spLocks noGrp="1"/>
-          </p:cNvSpPr>
-          <p:nvPr>
-            <p:ph type="sldImg" idx="2"/>
-          </p:nvPr>
-        </p:nvSpPr>
-        <p:spPr/>
-      </p:sp>
-      <p:sp>
-        <p:nvSpPr>
-          <p:cNvPr id="3" name="Notes Placeholder 2"/>
-          <p:cNvSpPr>
-            <a:spLocks noGrp="1"/>
-          </p:cNvSpPr>
-          <p:nvPr>
-            <p:ph type="body" idx="3" sz="quarter"/>
-          </p:nvPr>
-        </p:nvSpPr>
-        <p:spPr/>
-        <p:txBody>
-          <a:bodyPr/>
-          <a:lstStyle/>
-          <a:p>
-            <a:r>
-              <a:t>【Slide 8 結語與 Q&amp;A 口述重點】</a:t>
-            </a:r>
-          </a:p>
-          <a:p>
-            <a:r>
-              <a:t>感謝各位鄰居耐心的聆聽。</a:t>
-            </a:r>
-          </a:p>
-          <a:p>
-            <a:r>
-              <a:t>桌上這套完整的法定卷宗、地籍圖和新光銀行定存單存根，大家都可以親自翻閱核對。</a:t>
-            </a:r>
-          </a:p>
-          <a:p>
-            <a:r>
-              <a:t>如果大家沒有任何疑問，我們今天就在連署申請書上簽下這 6 個名字，讓我們攜手打造屬於大境自己的安心家園！</a:t>
-            </a:r>
-          </a:p>
-          <a:p>
-            <a:r>
-              <a:t>現在開放大家提問，我一一為大家解答。</a:t>
-            </a:r>
-          </a:p>
-        </p:txBody>
-      </p:sp>
-      <p:sp>
-        <p:nvSpPr>
-          <p:cNvPr id="4" name="Slide Number Placeholder 3"/>
-          <p:cNvSpPr>
-            <a:spLocks noGrp="1"/>
-          </p:cNvSpPr>
-          <p:nvPr>
-            <p:ph type="sldNum" idx="5" sz="quarter"/>
-          </p:nvPr>
-        </p:nvSpPr>
-        <p:spPr/>
-      </p:sp>
-    </p:spTree>
-  </p:cSld>
-  <p:clrMapOvr>
-    <a:masterClrMapping/>
-  </p:clrMapOvr>
-</p:notes>
 </file>
 
 <file path=ppt/slideLayouts/slideLayout1.xml><?xml version="1.0" encoding="utf-8"?>
@@ -6425,6 +5290,7 @@
                     <a:bodyPr/>
                     <a:lstStyle/>
                     <a:p>
+                      <a:pPr algn="r"/>
                       <a:r>
                         <a:rPr sz="900" b="1">
                           <a:solidFill>
@@ -6493,6 +5359,7 @@
                     <a:bodyPr/>
                     <a:lstStyle/>
                     <a:p>
+                      <a:pPr algn="r"/>
                       <a:r>
                         <a:rPr sz="850" b="0">
                           <a:solidFill>
@@ -6562,6 +5429,7 @@
                     <a:bodyPr/>
                     <a:lstStyle/>
                     <a:p>
+                      <a:pPr algn="r"/>
                       <a:r>
                         <a:rPr sz="850" b="0">
                           <a:solidFill>
@@ -6631,6 +5499,7 @@
                     <a:bodyPr/>
                     <a:lstStyle/>
                     <a:p>
+                      <a:pPr algn="r"/>
                       <a:r>
                         <a:rPr sz="850" b="0">
                           <a:solidFill>
@@ -6700,6 +5569,7 @@
                     <a:bodyPr/>
                     <a:lstStyle/>
                     <a:p>
+                      <a:pPr algn="r"/>
                       <a:r>
                         <a:rPr sz="850" b="1">
                           <a:solidFill>
@@ -7159,6 +6029,7 @@
                     <a:bodyPr/>
                     <a:lstStyle/>
                     <a:p>
+                      <a:pPr algn="r"/>
                       <a:r>
                         <a:rPr sz="900" b="1">
                           <a:solidFill>
@@ -7227,6 +6098,7 @@
                     <a:bodyPr/>
                     <a:lstStyle/>
                     <a:p>
+                      <a:pPr algn="r"/>
                       <a:r>
                         <a:rPr sz="850" b="0">
                           <a:solidFill>
@@ -7295,6 +6167,7 @@
                     <a:bodyPr/>
                     <a:lstStyle/>
                     <a:p>
+                      <a:pPr algn="r"/>
                       <a:r>
                         <a:rPr sz="850" b="0">
                           <a:solidFill>
@@ -7363,6 +6236,7 @@
                     <a:bodyPr/>
                     <a:lstStyle/>
                     <a:p>
+                      <a:pPr algn="r"/>
                       <a:r>
                         <a:rPr sz="850" b="0">
                           <a:solidFill>
@@ -7431,6 +6305,7 @@
                     <a:bodyPr/>
                     <a:lstStyle/>
                     <a:p>
+                      <a:pPr algn="r"/>
                       <a:r>
                         <a:rPr sz="850" b="0">
                           <a:solidFill>
@@ -7499,6 +6374,7 @@
                     <a:bodyPr/>
                     <a:lstStyle/>
                     <a:p>
+                      <a:pPr algn="r"/>
                       <a:r>
                         <a:rPr sz="850" b="1">
                           <a:solidFill>
@@ -9460,324 +8336,4 @@
   </a:objectDefaults>
   <a:extraClrSchemeLst/>
 </a:theme>
-</file>
-
-<file path=ppt/theme/theme2.xml><?xml version="1.0" encoding="utf-8"?>
-<a:theme xmlns:a="http://schemas.openxmlformats.org/drawingml/2006/main" name="Office Theme">
-  <a:themeElements>
-    <a:clrScheme name="Office">
-      <a:dk1>
-        <a:sysClr val="windowText" lastClr="000000"/>
-      </a:dk1>
-      <a:lt1>
-        <a:sysClr val="window" lastClr="FFFFFF"/>
-      </a:lt1>
-      <a:dk2>
-        <a:srgbClr val="1F497D"/>
-      </a:dk2>
-      <a:lt2>
-        <a:srgbClr val="EEECE1"/>
-      </a:lt2>
-      <a:accent1>
-        <a:srgbClr val="4F81BD"/>
-      </a:accent1>
-      <a:accent2>
-        <a:srgbClr val="C0504D"/>
-      </a:accent2>
-      <a:accent3>
-        <a:srgbClr val="9BBB59"/>
-      </a:accent3>
-      <a:accent4>
-        <a:srgbClr val="8064A2"/>
-      </a:accent4>
-      <a:accent5>
-        <a:srgbClr val="4BACC6"/>
-      </a:accent5>
-      <a:accent6>
-        <a:srgbClr val="F79646"/>
-      </a:accent6>
-      <a:hlink>
-        <a:srgbClr val="0000FF"/>
-      </a:hlink>
-      <a:folHlink>
-        <a:srgbClr val="800080"/>
-      </a:folHlink>
-    </a:clrScheme>
-    <a:fontScheme name="Office">
-      <a:majorFont>
-        <a:latin typeface="Calibri"/>
-        <a:ea typeface=""/>
-        <a:cs typeface=""/>
-        <a:font script="Jpan" typeface="ＭＳ Ｐゴシック"/>
-        <a:font script="Hang" typeface="맑은 고딕"/>
-        <a:font script="Hans" typeface="宋体"/>
-        <a:font script="Hant" typeface="新細明體"/>
-        <a:font script="Arab" typeface="Times New Roman"/>
-        <a:font script="Hebr" typeface="Times New Roman"/>
-        <a:font script="Thai" typeface="Angsana New"/>
-        <a:font script="Ethi" typeface="Nyala"/>
-        <a:font script="Beng" typeface="Vrinda"/>
-        <a:font script="Gujr" typeface="Shruti"/>
-        <a:font script="Khmr" typeface="MoolBoran"/>
-        <a:font script="Knda" typeface="Tunga"/>
-        <a:font script="Guru" typeface="Raavi"/>
-        <a:font script="Cans" typeface="Euphemia"/>
-        <a:font script="Cher" typeface="Plantagenet Cherokee"/>
-        <a:font script="Yiii" typeface="Microsoft Yi Baiti"/>
-        <a:font script="Tibt" typeface="Microsoft Himalaya"/>
-        <a:font script="Thaa" typeface="MV Boli"/>
-        <a:font script="Deva" typeface="Mangal"/>
-        <a:font script="Telu" typeface="Gautami"/>
-        <a:font script="Taml" typeface="Latha"/>
-        <a:font script="Syrc" typeface="Estrangelo Edessa"/>
-        <a:font script="Orya" typeface="Kalinga"/>
-        <a:font script="Mlym" typeface="Kartika"/>
-        <a:font script="Laoo" typeface="DokChampa"/>
-        <a:font script="Sinh" typeface="Iskoola Pota"/>
-        <a:font script="Mong" typeface="Mongolian Baiti"/>
-        <a:font script="Viet" typeface="Times New Roman"/>
-        <a:font script="Uigh" typeface="Microsoft Uighur"/>
-        <a:font script="Geor" typeface="Sylfaen"/>
-      </a:majorFont>
-      <a:minorFont>
-        <a:latin typeface="Calibri"/>
-        <a:ea typeface=""/>
-        <a:cs typeface=""/>
-        <a:font script="Jpan" typeface="ＭＳ Ｐゴシック"/>
-        <a:font script="Hang" typeface="맑은 고딕"/>
-        <a:font script="Hans" typeface="宋体"/>
-        <a:font script="Hant" typeface="新細明體"/>
-        <a:font script="Arab" typeface="Arial"/>
-        <a:font script="Hebr" typeface="Arial"/>
-        <a:font script="Thai" typeface="Cordia New"/>
-        <a:font script="Ethi" typeface="Nyala"/>
-        <a:font script="Beng" typeface="Vrinda"/>
-        <a:font script="Gujr" typeface="Shruti"/>
-        <a:font script="Khmr" typeface="DaunPenh"/>
-        <a:font script="Knda" typeface="Tunga"/>
-        <a:font script="Guru" typeface="Raavi"/>
-        <a:font script="Cans" typeface="Euphemia"/>
-        <a:font script="Cher" typeface="Plantagenet Cherokee"/>
-        <a:font script="Yiii" typeface="Microsoft Yi Baiti"/>
-        <a:font script="Tibt" typeface="Microsoft Himalaya"/>
-        <a:font script="Thaa" typeface="MV Boli"/>
-        <a:font script="Deva" typeface="Mangal"/>
-        <a:font script="Telu" typeface="Gautami"/>
-        <a:font script="Taml" typeface="Latha"/>
-        <a:font script="Syrc" typeface="Estrangelo Edessa"/>
-        <a:font script="Orya" typeface="Kalinga"/>
-        <a:font script="Mlym" typeface="Kartika"/>
-        <a:font script="Laoo" typeface="DokChampa"/>
-        <a:font script="Sinh" typeface="Iskoola Pota"/>
-        <a:font script="Mong" typeface="Mongolian Baiti"/>
-        <a:font script="Viet" typeface="Arial"/>
-        <a:font script="Uigh" typeface="Microsoft Uighur"/>
-        <a:font script="Geor" typeface="Sylfaen"/>
-      </a:minorFont>
-    </a:fontScheme>
-    <a:fmtScheme name="Office">
-      <a:fillStyleLst>
-        <a:solidFill>
-          <a:schemeClr val="phClr"/>
-        </a:solidFill>
-        <a:gradFill rotWithShape="1">
-          <a:gsLst>
-            <a:gs pos="0">
-              <a:schemeClr val="phClr">
-                <a:tint val="50000"/>
-                <a:satMod val="300000"/>
-              </a:schemeClr>
-            </a:gs>
-            <a:gs pos="35000">
-              <a:schemeClr val="phClr">
-                <a:tint val="37000"/>
-                <a:satMod val="300000"/>
-              </a:schemeClr>
-            </a:gs>
-            <a:gs pos="100000">
-              <a:schemeClr val="phClr">
-                <a:tint val="15000"/>
-                <a:satMod val="350000"/>
-              </a:schemeClr>
-            </a:gs>
-          </a:gsLst>
-          <a:lin ang="16200000" scaled="1"/>
-        </a:gradFill>
-        <a:gradFill rotWithShape="1">
-          <a:gsLst>
-            <a:gs pos="0">
-              <a:schemeClr val="phClr">
-                <a:tint val="100000"/>
-                <a:shade val="100000"/>
-                <a:satMod val="130000"/>
-              </a:schemeClr>
-            </a:gs>
-            <a:gs pos="100000">
-              <a:schemeClr val="phClr">
-                <a:tint val="50000"/>
-                <a:shade val="100000"/>
-                <a:satMod val="350000"/>
-              </a:schemeClr>
-            </a:gs>
-          </a:gsLst>
-          <a:lin ang="16200000" scaled="0"/>
-        </a:gradFill>
-      </a:fillStyleLst>
-      <a:lnStyleLst>
-        <a:ln w="9525" cap="flat" cmpd="sng" algn="ctr">
-          <a:solidFill>
-            <a:schemeClr val="phClr">
-              <a:shade val="95000"/>
-              <a:satMod val="105000"/>
-            </a:schemeClr>
-          </a:solidFill>
-          <a:prstDash val="solid"/>
-        </a:ln>
-        <a:ln w="25400" cap="flat" cmpd="sng" algn="ctr">
-          <a:solidFill>
-            <a:schemeClr val="phClr"/>
-          </a:solidFill>
-          <a:prstDash val="solid"/>
-        </a:ln>
-        <a:ln w="38100" cap="flat" cmpd="sng" algn="ctr">
-          <a:solidFill>
-            <a:schemeClr val="phClr"/>
-          </a:solidFill>
-          <a:prstDash val="solid"/>
-        </a:ln>
-      </a:lnStyleLst>
-      <a:effectStyleLst>
-        <a:effectStyle>
-          <a:effectLst>
-            <a:outerShdw blurRad="40000" dist="20000" dir="5400000" rotWithShape="0">
-              <a:srgbClr val="000000">
-                <a:alpha val="38000"/>
-              </a:srgbClr>
-            </a:outerShdw>
-          </a:effectLst>
-        </a:effectStyle>
-        <a:effectStyle>
-          <a:effectLst>
-            <a:outerShdw blurRad="40000" dist="23000" dir="5400000" rotWithShape="0">
-              <a:srgbClr val="000000">
-                <a:alpha val="35000"/>
-              </a:srgbClr>
-            </a:outerShdw>
-          </a:effectLst>
-        </a:effectStyle>
-        <a:effectStyle>
-          <a:effectLst>
-            <a:outerShdw blurRad="40000" dist="23000" dir="5400000" rotWithShape="0">
-              <a:srgbClr val="000000">
-                <a:alpha val="35000"/>
-              </a:srgbClr>
-            </a:outerShdw>
-          </a:effectLst>
-          <a:scene3d>
-            <a:camera prst="orthographicFront">
-              <a:rot lat="0" lon="0" rev="0"/>
-            </a:camera>
-            <a:lightRig rig="threePt" dir="t">
-              <a:rot lat="0" lon="0" rev="1200000"/>
-            </a:lightRig>
-          </a:scene3d>
-          <a:sp3d>
-            <a:bevelT w="63500" h="25400"/>
-          </a:sp3d>
-        </a:effectStyle>
-      </a:effectStyleLst>
-      <a:bgFillStyleLst>
-        <a:solidFill>
-          <a:schemeClr val="phClr"/>
-        </a:solidFill>
-        <a:gradFill rotWithShape="1">
-          <a:gsLst>
-            <a:gs pos="0">
-              <a:schemeClr val="phClr">
-                <a:tint val="40000"/>
-                <a:satMod val="350000"/>
-              </a:schemeClr>
-            </a:gs>
-            <a:gs pos="40000">
-              <a:schemeClr val="phClr">
-                <a:tint val="45000"/>
-                <a:shade val="99000"/>
-                <a:satMod val="350000"/>
-              </a:schemeClr>
-            </a:gs>
-            <a:gs pos="100000">
-              <a:schemeClr val="phClr">
-                <a:shade val="20000"/>
-                <a:satMod val="255000"/>
-              </a:schemeClr>
-            </a:gs>
-          </a:gsLst>
-          <a:path path="circle">
-            <a:fillToRect l="50000" t="-80000" r="50000" b="180000"/>
-          </a:path>
-        </a:gradFill>
-        <a:gradFill rotWithShape="1">
-          <a:gsLst>
-            <a:gs pos="0">
-              <a:schemeClr val="phClr">
-                <a:tint val="80000"/>
-                <a:satMod val="300000"/>
-              </a:schemeClr>
-            </a:gs>
-            <a:gs pos="100000">
-              <a:schemeClr val="phClr">
-                <a:shade val="30000"/>
-                <a:satMod val="200000"/>
-              </a:schemeClr>
-            </a:gs>
-          </a:gsLst>
-          <a:path path="circle">
-            <a:fillToRect l="50000" t="50000" r="50000" b="50000"/>
-          </a:path>
-        </a:gradFill>
-      </a:bgFillStyleLst>
-    </a:fmtScheme>
-  </a:themeElements>
-  <a:objectDefaults>
-    <a:spDef>
-      <a:spPr/>
-      <a:bodyPr/>
-      <a:lstStyle/>
-      <a:style>
-        <a:lnRef idx="1">
-          <a:schemeClr val="accent1"/>
-        </a:lnRef>
-        <a:fillRef idx="3">
-          <a:schemeClr val="accent1"/>
-        </a:fillRef>
-        <a:effectRef idx="2">
-          <a:schemeClr val="accent1"/>
-        </a:effectRef>
-        <a:fontRef idx="minor">
-          <a:schemeClr val="lt1"/>
-        </a:fontRef>
-      </a:style>
-    </a:spDef>
-    <a:lnDef>
-      <a:spPr/>
-      <a:bodyPr/>
-      <a:lstStyle/>
-      <a:style>
-        <a:lnRef idx="2">
-          <a:schemeClr val="accent1"/>
-        </a:lnRef>
-        <a:fillRef idx="0">
-          <a:schemeClr val="accent1"/>
-        </a:fillRef>
-        <a:effectRef idx="1">
-          <a:schemeClr val="accent1"/>
-        </a:effectRef>
-        <a:fontRef idx="minor">
-          <a:schemeClr val="tx1"/>
-        </a:fontRef>
-      </a:style>
-    </a:lnDef>
-  </a:objectDefaults>
-  <a:extraClrSchemeLst/>
-</a:theme>
 </file>
</xml_diff>